<commit_message>
docs: tia-select 0.1.0 is on PyPI
Verified by installing from the index into a clean venv, not by trusting the
upload's 200: pip install tia-select, tia --version reports 0.1.0, the console
script and the pytest plugin both register.

The README's install instruction is now true, so it is written down. The status
line no longer says pre-alpha, and says instead that the tool has missed twice
and where both are root-caused — a published package should not be the moment
that claim gets quieter.

Deck updated: publication moves from 'next' to 'delivered'.
</commit_message>
<xml_diff>
--- a/docs/tia-review-2.pptx
+++ b/docs/tia-review-2.pptx
@@ -6960,6 +6960,30 @@
                 <a:ea typeface="Calibri" pitchFamily="34" charset="-122"/>
                 <a:cs typeface="Calibri" pitchFamily="34" charset="-120"/>
               </a:rPr>
+              <a:t>pip install tia-select — published, 0.1.0</a:t>
+            </a:r>
+            <a:endParaRPr lang="en-US" sz="1100" dirty="0"/>
+          </a:p>
+          <a:p>
+            <a:pPr marL="342900" indent="-342900">
+              <a:lnSpc>
+                <a:spcPts val="1600"/>
+              </a:lnSpc>
+              <a:spcAft>
+                <a:spcPts val="800"/>
+              </a:spcAft>
+              <a:buSzPct val="100000"/>
+              <a:buChar char="•"/>
+            </a:pPr>
+            <a:r>
+              <a:rPr lang="en-US" sz="1100" dirty="0">
+                <a:solidFill>
+                  <a:srgbClr val="17232F"/>
+                </a:solidFill>
+                <a:latin typeface="Calibri" pitchFamily="34" charset="0"/>
+                <a:ea typeface="Calibri" pitchFamily="34" charset="-122"/>
+                <a:cs typeface="Calibri" pitchFamily="34" charset="-120"/>
+              </a:rPr>
               <a:t>github.com/Tanmay-Singh-24/tia — public, CI green on 3.11 and 3.12</a:t>
             </a:r>
             <a:endParaRPr lang="en-US" sz="1100" dirty="0"/>
@@ -7094,30 +7118,6 @@
                 <a:cs typeface="Calibri" pitchFamily="34" charset="-120"/>
               </a:rPr>
               <a:t>Third corpus repository (black, held in reserve)</a:t>
-            </a:r>
-            <a:endParaRPr lang="en-US" sz="1100" dirty="0"/>
-          </a:p>
-          <a:p>
-            <a:pPr marL="342900" indent="-342900">
-              <a:lnSpc>
-                <a:spcPts val="1600"/>
-              </a:lnSpc>
-              <a:spcAft>
-                <a:spcPts val="800"/>
-              </a:spcAft>
-              <a:buSzPct val="100000"/>
-              <a:buChar char="•"/>
-            </a:pPr>
-            <a:r>
-              <a:rPr lang="en-US" sz="1100" dirty="0">
-                <a:solidFill>
-                  <a:srgbClr val="17232F"/>
-                </a:solidFill>
-                <a:latin typeface="Calibri" pitchFamily="34" charset="0"/>
-                <a:ea typeface="Calibri" pitchFamily="34" charset="-122"/>
-                <a:cs typeface="Calibri" pitchFamily="34" charset="-120"/>
-              </a:rPr>
-              <a:t>PyPI release as tia-select</a:t>
             </a:r>
             <a:endParaRPr lang="en-US" sz="1100" dirty="0"/>
           </a:p>

</xml_diff>

<commit_message>
docs: publish the re-measured results and correct the attrs time figure
The attrs saving was published as 58.4%, set by one mutant that hung the
suite for 291 s. Measured as the mean share saved per change (D-0020) it is
42.7%; scrapy is 66.9%. README, SAFETY, CHANGELOG and the Review 2 deck now
quote the re-measured runs.
</commit_message>
<xml_diff>
--- a/docs/tia-review-2.pptx
+++ b/docs/tia-review-2.pptx
@@ -1393,7 +1393,7 @@
           <a:p>
             <a:r>
               <a:rPr lang="en-US" dirty="0"/>
-              <a:t>A project whose contribution is reproducible measurement has to be hardest on its own measurements. Both faults are written up in DECISIONS with what now prevents them.</a:t>
+              <a:t>A project whose contribution is reproducible measurement has to be hardest on its own measurements. All three faults are written up in DECISIONS with what now prevents them.</a:t>
             </a:r>
             <a:endParaRPr lang="en-US" dirty="0"/>
           </a:p>
@@ -1965,7 +1965,7 @@
                 <a:ea typeface="Calibri" pitchFamily="34" charset="-122"/>
                 <a:cs typeface="Calibri" pitchFamily="34" charset="-120"/>
               </a:rPr>
-              <a:t>Zero missed defects across 211 injected into two real codebases, at up to 65.2% less test time.</a:t>
+              <a:t>Zero missed defects across 213 injected into two real codebases, saving up to 66.9% of test time per change.</a:t>
             </a:r>
             <a:endParaRPr lang="en-US" sz="1400" dirty="0"/>
           </a:p>
@@ -6224,7 +6224,7 @@
                 <a:ea typeface="Calibri" pitchFamily="34" charset="-122"/>
                 <a:cs typeface="Calibri" pitchFamily="34" charset="-120"/>
               </a:rPr>
-              <a:t>What we claim instead is bounded, measured safety: 0 misses in 211 non-equivalent injected defects, on two real codebases, reproducible from the pinned corpus with one command.</a:t>
+              <a:t>What we claim instead is bounded, measured safety: 0 misses in 213 non-equivalent injected defects, on two real codebases, reproducible from the pinned corpus with one command.</a:t>
             </a:r>
             <a:endParaRPr lang="en-US" sz="1300" dirty="0"/>
           </a:p>
@@ -7093,7 +7093,7 @@
                 <a:ea typeface="Calibri" pitchFamily="34" charset="-122"/>
                 <a:cs typeface="Calibri" pitchFamily="34" charset="-120"/>
               </a:rPr>
-              <a:t>Sweep the closure limit against net reduction</a:t>
+              <a:t>Sweep the closure limit against time saved per change</a:t>
             </a:r>
             <a:endParaRPr lang="en-US" sz="1100" dirty="0"/>
           </a:p>
@@ -7207,7 +7207,7 @@
                 <a:ea typeface="Cambria" pitchFamily="34" charset="-122"/>
                 <a:cs typeface="Cambria" pitchFamily="34" charset="-120"/>
               </a:rPr>
-              <a:t>0 misses in 211 injected defects. 65.2% less test time on a 4,371-test suite. Four bugs found by our own evaluation — including one the import graph itself introduced.</a:t>
+              <a:t>0 misses in 213 injected defects. 66.9% of test time saved per change on a 4,371-test suite. Four bugs found by our own evaluation — including one the import graph itself introduced.</a:t>
             </a:r>
             <a:endParaRPr lang="en-US" sz="1500" dirty="0"/>
           </a:p>
@@ -7376,7 +7376,7 @@
                 <a:ea typeface="Cambria" pitchFamily="34" charset="-122"/>
                 <a:cs typeface="Cambria" pitchFamily="34" charset="-120"/>
               </a:rPr>
-              <a:t>0 / 211</a:t>
+              <a:t>0 / 213</a:t>
             </a:r>
             <a:endParaRPr lang="en-US" sz="3400" dirty="0"/>
           </a:p>
@@ -7520,7 +7520,7 @@
                 <a:ea typeface="Cambria" pitchFamily="34" charset="-122"/>
                 <a:cs typeface="Cambria" pitchFamily="34" charset="-120"/>
               </a:rPr>
-              <a:t>65.2%</a:t>
+              <a:t>66.9%</a:t>
             </a:r>
             <a:endParaRPr lang="en-US" sz="3400" dirty="0"/>
           </a:p>
@@ -7559,7 +7559,7 @@
                 <a:ea typeface="Calibri" pitchFamily="34" charset="-122"/>
                 <a:cs typeface="Calibri" pitchFamily="34" charset="-120"/>
               </a:rPr>
-              <a:t>less test time on scrapy</a:t>
+              <a:t>test time saved per change</a:t>
             </a:r>
             <a:endParaRPr lang="en-US" sz="1200" dirty="0"/>
           </a:p>
@@ -7598,7 +7598,7 @@
                 <a:ea typeface="Calibri" pitchFamily="34" charset="-122"/>
                 <a:cs typeface="Calibri" pitchFamily="34" charset="-120"/>
               </a:rPr>
-              <a:t>58.4% on attrs</a:t>
+              <a:t>scrapy; 42.7% on attrs</a:t>
             </a:r>
             <a:endParaRPr lang="en-US" sz="1000" dirty="0"/>
           </a:p>
@@ -7664,7 +7664,7 @@
                 <a:ea typeface="Cambria" pitchFamily="34" charset="-122"/>
                 <a:cs typeface="Cambria" pitchFamily="34" charset="-120"/>
               </a:rPr>
-              <a:t>29.6%</a:t>
+              <a:t>28.6%</a:t>
             </a:r>
             <a:endParaRPr lang="en-US" sz="3400" dirty="0"/>
           </a:p>
@@ -7742,7 +7742,7 @@
                 <a:ea typeface="Calibri" pitchFamily="34" charset="-122"/>
                 <a:cs typeface="Calibri" pitchFamily="34" charset="-120"/>
               </a:rPr>
-              <a:t>50.5% on attrs — the honest cost</a:t>
+              <a:t>50.3% on attrs — the honest cost</a:t>
             </a:r>
             <a:endParaRPr lang="en-US" sz="1000" dirty="0"/>
           </a:p>
@@ -8250,7 +8250,7 @@
                           <a:ea typeface="Calibri" pitchFamily="34" charset="-122"/>
                           <a:cs typeface="Calibri" pitchFamily="34" charset="-120"/>
                         </a:rPr>
-                        <a:t>3.8 s</a:t>
+                        <a:t>3.9 s</a:t>
                       </a:r>
                       <a:endParaRPr lang="en-US" sz="1100" dirty="0">
                         <a:latin typeface="Calibri" charset="0"/>
@@ -8315,7 +8315,7 @@
                           <a:ea typeface="Calibri" pitchFamily="34" charset="-122"/>
                           <a:cs typeface="Calibri" pitchFamily="34" charset="-120"/>
                         </a:rPr>
-                        <a:t>52 s</a:t>
+                        <a:t>53.5 s</a:t>
                       </a:r>
                       <a:endParaRPr lang="en-US" sz="1100" dirty="0">
                         <a:latin typeface="Calibri" charset="0"/>
@@ -8447,7 +8447,7 @@
                           <a:ea typeface="Calibri" pitchFamily="34" charset="-122"/>
                           <a:cs typeface="Calibri" pitchFamily="34" charset="-120"/>
                         </a:rPr>
-                        <a:t>184</a:t>
+                        <a:t>185</a:t>
                       </a:r>
                       <a:endParaRPr lang="en-US" sz="1100" dirty="0">
                         <a:latin typeface="Calibri" charset="0"/>
@@ -8512,7 +8512,7 @@
                           <a:ea typeface="Calibri" pitchFamily="34" charset="-122"/>
                           <a:cs typeface="Calibri" pitchFamily="34" charset="-120"/>
                         </a:rPr>
-                        <a:t>27</a:t>
+                        <a:t>28</a:t>
                       </a:r>
                       <a:endParaRPr lang="en-US" sz="1100" dirty="0">
                         <a:latin typeface="Calibri" charset="0"/>
@@ -8841,7 +8841,7 @@
                           <a:ea typeface="Calibri" pitchFamily="34" charset="-122"/>
                           <a:cs typeface="Calibri" pitchFamily="34" charset="-120"/>
                         </a:rPr>
-                        <a:t>50.5%</a:t>
+                        <a:t>50.3%</a:t>
                       </a:r>
                       <a:endParaRPr lang="en-US" sz="1100" dirty="0">
                         <a:latin typeface="Calibri" charset="0"/>
@@ -8906,7 +8906,7 @@
                           <a:ea typeface="Calibri" pitchFamily="34" charset="-122"/>
                           <a:cs typeface="Calibri" pitchFamily="34" charset="-120"/>
                         </a:rPr>
-                        <a:t>29.6%</a:t>
+                        <a:t>28.6%</a:t>
                       </a:r>
                       <a:endParaRPr lang="en-US" sz="1100" dirty="0">
                         <a:latin typeface="Calibri" charset="0"/>
@@ -8973,7 +8973,7 @@
                           <a:ea typeface="Calibri" pitchFamily="34" charset="-122"/>
                           <a:cs typeface="Calibri" pitchFamily="34" charset="-120"/>
                         </a:rPr>
-                        <a:t>Net time reduction</a:t>
+                        <a:t>Time saved per change</a:t>
                       </a:r>
                       <a:endParaRPr lang="en-US" sz="1100" dirty="0">
                         <a:latin typeface="Calibri" charset="0"/>
@@ -9038,7 +9038,7 @@
                           <a:ea typeface="Calibri" pitchFamily="34" charset="-122"/>
                           <a:cs typeface="Calibri" pitchFamily="34" charset="-120"/>
                         </a:rPr>
-                        <a:t>58.4%</a:t>
+                        <a:t>42.7%</a:t>
                       </a:r>
                       <a:endParaRPr lang="en-US" sz="1100" dirty="0">
                         <a:latin typeface="Calibri" charset="0"/>
@@ -9103,7 +9103,7 @@
                           <a:ea typeface="Calibri" pitchFamily="34" charset="-122"/>
                           <a:cs typeface="Calibri" pitchFamily="34" charset="-120"/>
                         </a:rPr>
-                        <a:t>65.2%</a:t>
+                        <a:t>66.9%</a:t>
                       </a:r>
                       <a:endParaRPr lang="en-US" sz="1100" dirty="0">
                         <a:latin typeface="Calibri" charset="0"/>
@@ -9235,7 +9235,7 @@
                           <a:ea typeface="Calibri" pitchFamily="34" charset="-122"/>
                           <a:cs typeface="Calibri" pitchFamily="34" charset="-120"/>
                         </a:rPr>
-                        <a:t>55.2%</a:t>
+                        <a:t>50.0%</a:t>
                       </a:r>
                       <a:endParaRPr lang="en-US" sz="1100" dirty="0">
                         <a:latin typeface="Calibri" charset="0"/>
@@ -9300,7 +9300,7 @@
                           <a:ea typeface="Calibri" pitchFamily="34" charset="-122"/>
                           <a:cs typeface="Calibri" pitchFamily="34" charset="-120"/>
                         </a:rPr>
-                        <a:t>9.8%</a:t>
+                        <a:t>11.2%</a:t>
                       </a:r>
                       <a:endParaRPr lang="en-US" sz="1100" dirty="0">
                         <a:latin typeface="Calibri" charset="0"/>
@@ -12966,7 +12966,7 @@
                           <a:ea typeface="Calibri" pitchFamily="34" charset="-122"/>
                           <a:cs typeface="Calibri" pitchFamily="34" charset="-120"/>
                         </a:rPr>
-                        <a:t>0 / 184</a:t>
+                        <a:t>0 / 185</a:t>
                       </a:r>
                       <a:endParaRPr lang="en-US" sz="1100" dirty="0">
                         <a:latin typeface="Calibri" charset="0"/>
@@ -13031,7 +13031,7 @@
                           <a:ea typeface="Calibri" pitchFamily="34" charset="-122"/>
                           <a:cs typeface="Calibri" pitchFamily="34" charset="-120"/>
                         </a:rPr>
-                        <a:t>0 / 184</a:t>
+                        <a:t>0 / 185</a:t>
                       </a:r>
                       <a:endParaRPr lang="en-US" sz="1100" dirty="0">
                         <a:latin typeface="Calibri" charset="0"/>
@@ -13096,7 +13096,7 @@
                           <a:ea typeface="Calibri" pitchFamily="34" charset="-122"/>
                           <a:cs typeface="Calibri" pitchFamily="34" charset="-120"/>
                         </a:rPr>
-                        <a:t>0 / 27</a:t>
+                        <a:t>0 / 28</a:t>
                       </a:r>
                       <a:endParaRPr lang="en-US" sz="1100" dirty="0">
                         <a:latin typeface="Calibri" charset="0"/>
@@ -13161,7 +13161,7 @@
                           <a:ea typeface="Calibri" pitchFamily="34" charset="-122"/>
                           <a:cs typeface="Calibri" pitchFamily="34" charset="-120"/>
                         </a:rPr>
-                        <a:t>0 / 27</a:t>
+                        <a:t>0 / 28</a:t>
                       </a:r>
                       <a:endParaRPr lang="en-US" sz="1100" dirty="0">
                         <a:latin typeface="Calibri" charset="0"/>
@@ -13293,7 +13293,7 @@
                           <a:ea typeface="Calibri" pitchFamily="34" charset="-122"/>
                           <a:cs typeface="Calibri" pitchFamily="34" charset="-120"/>
                         </a:rPr>
-                        <a:t>52.7%</a:t>
+                        <a:t>52.4%</a:t>
                       </a:r>
                       <a:endParaRPr lang="en-US" sz="1100" dirty="0">
                         <a:latin typeface="Calibri" charset="0"/>
@@ -13358,7 +13358,7 @@
                           <a:ea typeface="Calibri" pitchFamily="34" charset="-122"/>
                           <a:cs typeface="Calibri" pitchFamily="34" charset="-120"/>
                         </a:rPr>
-                        <a:t>50.5%</a:t>
+                        <a:t>50.3%</a:t>
                       </a:r>
                       <a:endParaRPr lang="en-US" sz="1100" dirty="0">
                         <a:latin typeface="Calibri" charset="0"/>
@@ -13423,7 +13423,7 @@
                           <a:ea typeface="Calibri" pitchFamily="34" charset="-122"/>
                           <a:cs typeface="Calibri" pitchFamily="34" charset="-120"/>
                         </a:rPr>
-                        <a:t>59.3%</a:t>
+                        <a:t>57.1%</a:t>
                       </a:r>
                       <a:endParaRPr lang="en-US" sz="1100" dirty="0">
                         <a:latin typeface="Calibri" charset="0"/>
@@ -13488,7 +13488,7 @@
                           <a:ea typeface="Calibri" pitchFamily="34" charset="-122"/>
                           <a:cs typeface="Calibri" pitchFamily="34" charset="-120"/>
                         </a:rPr>
-                        <a:t>29.6%</a:t>
+                        <a:t>28.6%</a:t>
                       </a:r>
                       <a:endParaRPr lang="en-US" sz="1100" dirty="0">
                         <a:latin typeface="Calibri" charset="0"/>
@@ -13555,7 +13555,7 @@
                           <a:ea typeface="Calibri" pitchFamily="34" charset="-122"/>
                           <a:cs typeface="Calibri" pitchFamily="34" charset="-120"/>
                         </a:rPr>
-                        <a:t>Net time reduction</a:t>
+                        <a:t>Time saved per change</a:t>
                       </a:r>
                       <a:endParaRPr lang="en-US" sz="1100" dirty="0">
                         <a:latin typeface="Calibri" charset="0"/>
@@ -13620,7 +13620,7 @@
                           <a:ea typeface="Calibri" pitchFamily="34" charset="-122"/>
                           <a:cs typeface="Calibri" pitchFamily="34" charset="-120"/>
                         </a:rPr>
-                        <a:t>57.0%</a:t>
+                        <a:t>41.9%</a:t>
                       </a:r>
                       <a:endParaRPr lang="en-US" sz="1100" dirty="0">
                         <a:latin typeface="Calibri" charset="0"/>
@@ -13685,7 +13685,7 @@
                           <a:ea typeface="Calibri" pitchFamily="34" charset="-122"/>
                           <a:cs typeface="Calibri" pitchFamily="34" charset="-120"/>
                         </a:rPr>
-                        <a:t>58.4%</a:t>
+                        <a:t>42.7%</a:t>
                       </a:r>
                       <a:endParaRPr lang="en-US" sz="1100" dirty="0">
                         <a:latin typeface="Calibri" charset="0"/>
@@ -13750,7 +13750,7 @@
                           <a:ea typeface="Calibri" pitchFamily="34" charset="-122"/>
                           <a:cs typeface="Calibri" pitchFamily="34" charset="-120"/>
                         </a:rPr>
-                        <a:t>40.4%</a:t>
+                        <a:t>44.2%</a:t>
                       </a:r>
                       <a:endParaRPr lang="en-US" sz="1100" dirty="0">
                         <a:latin typeface="Calibri" charset="0"/>
@@ -13815,7 +13815,7 @@
                           <a:ea typeface="Calibri" pitchFamily="34" charset="-122"/>
                           <a:cs typeface="Calibri" pitchFamily="34" charset="-120"/>
                         </a:rPr>
-                        <a:t>65.2%</a:t>
+                        <a:t>66.9%</a:t>
                       </a:r>
                       <a:endParaRPr lang="en-US" sz="1100" dirty="0">
                         <a:latin typeface="Calibri" charset="0"/>
@@ -13947,7 +13947,7 @@
                           <a:ea typeface="Calibri" pitchFamily="34" charset="-122"/>
                           <a:cs typeface="Calibri" pitchFamily="34" charset="-120"/>
                         </a:rPr>
-                        <a:t>62.5%</a:t>
+                        <a:t>50.0%</a:t>
                       </a:r>
                       <a:endParaRPr lang="en-US" sz="1100" dirty="0">
                         <a:latin typeface="Calibri" charset="0"/>
@@ -14012,7 +14012,7 @@
                           <a:ea typeface="Calibri" pitchFamily="34" charset="-122"/>
                           <a:cs typeface="Calibri" pitchFamily="34" charset="-120"/>
                         </a:rPr>
-                        <a:t>55.2%</a:t>
+                        <a:t>50.0%</a:t>
                       </a:r>
                       <a:endParaRPr lang="en-US" sz="1100" dirty="0">
                         <a:latin typeface="Calibri" charset="0"/>
@@ -14077,7 +14077,7 @@
                           <a:ea typeface="Calibri" pitchFamily="34" charset="-122"/>
                           <a:cs typeface="Calibri" pitchFamily="34" charset="-120"/>
                         </a:rPr>
-                        <a:t>25.0%</a:t>
+                        <a:t>31.2%</a:t>
                       </a:r>
                       <a:endParaRPr lang="en-US" sz="1100" dirty="0">
                         <a:latin typeface="Calibri" charset="0"/>
@@ -14142,7 +14142,7 @@
                           <a:ea typeface="Calibri" pitchFamily="34" charset="-122"/>
                           <a:cs typeface="Calibri" pitchFamily="34" charset="-120"/>
                         </a:rPr>
-                        <a:t>9.8%</a:t>
+                        <a:t>11.2%</a:t>
                       </a:r>
                       <a:endParaRPr lang="en-US" sz="1100" dirty="0">
                         <a:latin typeface="Calibri" charset="0"/>
@@ -14297,7 +14297,7 @@
                 <a:ea typeface="Calibri" pitchFamily="34" charset="-122"/>
                 <a:cs typeface="Calibri" pitchFamily="34" charset="-120"/>
               </a:rPr>
-              <a:t>On scrapy, whose suite takes 52 seconds, the graph halves the fallback rate and lifts the saving from 40.4% to 65.2%. On attrs, whose suite takes 3.9 seconds, it is worth almost nothing: 58.4% against 57.0%, with the fallback rate barely moving.</a:t>
+              <a:t>On scrapy, whose suite takes 53 seconds, the graph halves the fallback rate and lifts the saving from 44.2% to 66.9%. On attrs, whose suite takes 3.9 seconds, it is worth almost nothing: 42.7% against 41.9%, with the fallback rate barely moving.</a:t>
             </a:r>
             <a:endParaRPr lang="en-US" sz="1200" dirty="0"/>
           </a:p>
@@ -14429,7 +14429,7 @@
                 <a:ea typeface="Cambria" pitchFamily="34" charset="-122"/>
                 <a:cs typeface="Cambria" pitchFamily="34" charset="-120"/>
               </a:rPr>
-              <a:t>Two ways our own measurements lied</a:t>
+              <a:t>Three ways our own measurements lied</a:t>
             </a:r>
             <a:endParaRPr lang="en-US" sz="3400" dirty="0"/>
           </a:p>
@@ -14957,9 +14957,48 @@
                 <a:ea typeface="Calibri" pitchFamily="34" charset="-122"/>
                 <a:cs typeface="Calibri" pitchFamily="34" charset="-120"/>
               </a:rPr>
-              <a:t>net_reduction is computed inside the harness and excludes runs by exit code — a timeout measures a hang, not a suite. Recomputed, the published figure stands.</a:t>
+              <a:t>net_reduction is computed inside the harness and excludes runs by exit code — a timeout measures a hang, not a suite. That was not yet enough: see below.</a:t>
             </a:r>
             <a:endParaRPr lang="en-US" sz="1100" dirty="0"/>
+          </a:p>
+        </p:txBody>
+      </p:sp>
+      <p:sp>
+        <p:nvSpPr>
+          <p:cNvPr id="18" name="Text 16"/>
+          <p:cNvSpPr txBox="1"/>
+          <p:nvPr/>
+        </p:nvSpPr>
+        <p:spPr>
+          <a:xfrm>
+            <a:off x="640080" y="5897880"/>
+            <a:ext cx="10881360" cy="548640"/>
+          </a:xfrm>
+          <a:prstGeom prst="rect">
+            <a:avLst/>
+          </a:prstGeom>
+          <a:noFill/>
+          <a:ln/>
+        </p:spPr>
+        <p:txBody>
+          <a:bodyPr wrap="square" lIns="0" tIns="0" rIns="0" bIns="0" rtlCol="0" anchor="ctr"/>
+          <a:lstStyle/>
+          <a:p>
+            <a:pPr indent="0" marL="0">
+              <a:buNone/>
+            </a:pPr>
+            <a:r>
+              <a:rPr lang="en-US" sz="1200" b="1" dirty="0">
+                <a:solidFill>
+                  <a:srgbClr val="D1453B"/>
+                </a:solidFill>
+                <a:latin typeface="Calibri" pitchFamily="34" charset="0"/>
+                <a:ea typeface="Calibri" pitchFamily="34" charset="-122"/>
+                <a:cs typeface="Calibri" pitchFamily="34" charset="-120"/>
+              </a:rPr>
+              <a:t>A third, found re-measuring for 0.2.0: one mutant that hung the suite for 291 s set the published attrs saving at 58.4%. Measured per change, it is 42.7% (D-0020).</a:t>
+            </a:r>
+            <a:endParaRPr lang="en-US" sz="1200" dirty="0"/>
           </a:p>
         </p:txBody>
       </p:sp>

</xml_diff>